<commit_message>
Consolidate frontend into standalone HTML and update design doc
Co-Authored-By: Claude Sonnet 4.6 <noreply@anthropic.com>
</commit_message>
<xml_diff>
--- a/Design Documents/Power.Talks Design.pptx
+++ b/Design Documents/Power.Talks Design.pptx
@@ -779,7 +779,7 @@
           <a:p>
             <a:fld id="{DFA2CCE5-FDF4-4EB5-B6DF-6638599F3816}" type="datetimeFigureOut">
               <a:rPr lang="en-US" smtClean="0"/>
-              <a:t>8/28/2025</a:t>
+              <a:t>2/14/2026</a:t>
             </a:fld>
             <a:endParaRPr lang="en-US"/>
           </a:p>
@@ -1177,7 +1177,7 @@
           <a:p>
             <a:fld id="{7F9B76C0-E9A3-4470-8257-F1BB65905291}" type="datetime4">
               <a:rPr lang="en-US" smtClean="0"/>
-              <a:t>August 28, 2025</a:t>
+              <a:t>February 14, 2026</a:t>
             </a:fld>
             <a:endParaRPr lang="en-US"/>
           </a:p>
@@ -1347,7 +1347,7 @@
           <a:p>
             <a:fld id="{A17EF97D-A8AE-47F5-8736-0CABA45B003E}" type="datetime4">
               <a:rPr lang="en-US" smtClean="0"/>
-              <a:t>August 28, 2025</a:t>
+              <a:t>February 14, 2026</a:t>
             </a:fld>
             <a:endParaRPr lang="en-US"/>
           </a:p>
@@ -1527,7 +1527,7 @@
           <a:p>
             <a:fld id="{355C148C-EA94-4767-8899-E3BAAD414647}" type="datetime4">
               <a:rPr lang="en-US" smtClean="0"/>
-              <a:t>August 28, 2025</a:t>
+              <a:t>February 14, 2026</a:t>
             </a:fld>
             <a:endParaRPr lang="en-US"/>
           </a:p>
@@ -1697,7 +1697,7 @@
           <a:p>
             <a:fld id="{3CCD63B9-3A19-4C27-B386-133EC6F306C3}" type="datetime4">
               <a:rPr lang="en-US" smtClean="0"/>
-              <a:t>August 28, 2025</a:t>
+              <a:t>February 14, 2026</a:t>
             </a:fld>
             <a:endParaRPr lang="en-US"/>
           </a:p>
@@ -1943,7 +1943,7 @@
           <a:p>
             <a:fld id="{C561D307-5726-4724-ADF8-6E74855A60CB}" type="datetime4">
               <a:rPr lang="en-US" smtClean="0"/>
-              <a:t>August 28, 2025</a:t>
+              <a:t>February 14, 2026</a:t>
             </a:fld>
             <a:endParaRPr lang="en-US"/>
           </a:p>
@@ -2175,7 +2175,7 @@
           <a:p>
             <a:fld id="{47BD7BB7-7A78-402C-8216-C1408FEB382E}" type="datetime4">
               <a:rPr lang="en-US" smtClean="0"/>
-              <a:t>August 28, 2025</a:t>
+              <a:t>February 14, 2026</a:t>
             </a:fld>
             <a:endParaRPr lang="en-US" dirty="0"/>
           </a:p>
@@ -2542,7 +2542,7 @@
           <a:p>
             <a:fld id="{2742343E-F4D7-4E00-B9F2-5F6762BE5728}" type="datetime4">
               <a:rPr lang="en-US" smtClean="0"/>
-              <a:t>August 28, 2025</a:t>
+              <a:t>February 14, 2026</a:t>
             </a:fld>
             <a:endParaRPr lang="en-US"/>
           </a:p>
@@ -2660,7 +2660,7 @@
           <a:p>
             <a:fld id="{CAFE7F51-E863-42F8-8F2B-1F183A91573E}" type="datetime4">
               <a:rPr lang="en-US" smtClean="0"/>
-              <a:t>August 28, 2025</a:t>
+              <a:t>February 14, 2026</a:t>
             </a:fld>
             <a:endParaRPr lang="en-US"/>
           </a:p>
@@ -2755,7 +2755,7 @@
           <a:p>
             <a:fld id="{AF7E1F22-31CC-4E41-A2EC-86D92BE02BDC}" type="datetime4">
               <a:rPr lang="en-US" smtClean="0"/>
-              <a:t>August 28, 2025</a:t>
+              <a:t>February 14, 2026</a:t>
             </a:fld>
             <a:endParaRPr lang="en-US"/>
           </a:p>
@@ -3032,7 +3032,7 @@
           <a:p>
             <a:fld id="{76F11AC7-8CC2-470F-999F-1990D27EB8E9}" type="datetime4">
               <a:rPr lang="en-US" smtClean="0"/>
-              <a:t>August 28, 2025</a:t>
+              <a:t>February 14, 2026</a:t>
             </a:fld>
             <a:endParaRPr lang="en-US"/>
           </a:p>
@@ -3289,7 +3289,7 @@
           <a:p>
             <a:fld id="{61364922-0191-4802-88BC-FCAC60D60778}" type="datetime4">
               <a:rPr lang="en-US" smtClean="0"/>
-              <a:t>August 28, 2025</a:t>
+              <a:t>February 14, 2026</a:t>
             </a:fld>
             <a:endParaRPr lang="en-US"/>
           </a:p>
@@ -3502,7 +3502,7 @@
           <a:p>
             <a:fld id="{F3AFBC40-72A2-4E2B-BCF9-BA5DBFE1721A}" type="datetime4">
               <a:rPr lang="en-US" smtClean="0"/>
-              <a:t>August 28, 2025</a:t>
+              <a:t>February 14, 2026</a:t>
             </a:fld>
             <a:endParaRPr lang="en-US" dirty="0">
               <a:latin typeface="+mn-lt"/>
@@ -5015,53 +5015,244 @@
           </a:p>
         </p:txBody>
       </p:sp>
-      <p:pic>
-        <p:nvPicPr>
-          <p:cNvPr id="1026" name="Picture 2">
+      <p:grpSp>
+        <p:nvGrpSpPr>
+          <p:cNvPr id="7" name="Group 6">
             <a:extLst>
               <a:ext uri="{FF2B5EF4-FFF2-40B4-BE49-F238E27FC236}">
-                <a16:creationId xmlns:a16="http://schemas.microsoft.com/office/drawing/2014/main" id="{F85CDB6B-EF82-2EC0-595C-FBAE99F08029}"/>
+                <a16:creationId xmlns:a16="http://schemas.microsoft.com/office/drawing/2014/main" id="{8BC5EB05-9AE0-6FF6-895B-6673F74F5DFD}"/>
               </a:ext>
             </a:extLst>
           </p:cNvPr>
-          <p:cNvPicPr>
-            <a:picLocks noChangeAspect="1" noChangeArrowheads="1"/>
-          </p:cNvPicPr>
+          <p:cNvGrpSpPr/>
           <p:nvPr/>
-        </p:nvPicPr>
-        <p:blipFill>
-          <a:blip r:embed="rId2">
+        </p:nvGrpSpPr>
+        <p:grpSpPr>
+          <a:xfrm>
+            <a:off x="2028423" y="212501"/>
+            <a:ext cx="8020452" cy="6458755"/>
+            <a:chOff x="2028423" y="212501"/>
+            <a:chExt cx="8020452" cy="6458755"/>
+          </a:xfrm>
+        </p:grpSpPr>
+        <p:grpSp>
+          <p:nvGrpSpPr>
+            <p:cNvPr id="5" name="Group 4">
+              <a:extLst>
+                <a:ext uri="{FF2B5EF4-FFF2-40B4-BE49-F238E27FC236}">
+                  <a16:creationId xmlns:a16="http://schemas.microsoft.com/office/drawing/2014/main" id="{40FB8301-0212-B80E-31CF-A766B106D88B}"/>
+                </a:ext>
+              </a:extLst>
+            </p:cNvPr>
+            <p:cNvGrpSpPr/>
+            <p:nvPr/>
+          </p:nvGrpSpPr>
+          <p:grpSpPr>
+            <a:xfrm>
+              <a:off x="2143125" y="300038"/>
+              <a:ext cx="7905750" cy="6257925"/>
+              <a:chOff x="2143125" y="300038"/>
+              <a:chExt cx="7905750" cy="6257925"/>
+            </a:xfrm>
+          </p:grpSpPr>
+          <p:pic>
+            <p:nvPicPr>
+              <p:cNvPr id="1026" name="Picture 2">
+                <a:extLst>
+                  <a:ext uri="{FF2B5EF4-FFF2-40B4-BE49-F238E27FC236}">
+                    <a16:creationId xmlns:a16="http://schemas.microsoft.com/office/drawing/2014/main" id="{F85CDB6B-EF82-2EC0-595C-FBAE99F08029}"/>
+                  </a:ext>
+                </a:extLst>
+              </p:cNvPr>
+              <p:cNvPicPr>
+                <a:picLocks noChangeAspect="1" noChangeArrowheads="1"/>
+              </p:cNvPicPr>
+              <p:nvPr/>
+            </p:nvPicPr>
+            <p:blipFill>
+              <a:blip r:embed="rId2">
+                <a:extLst>
+                  <a:ext uri="{28A0092B-C50C-407E-A947-70E740481C1C}">
+                    <a14:useLocalDpi xmlns:a14="http://schemas.microsoft.com/office/drawing/2010/main" val="0"/>
+                  </a:ext>
+                </a:extLst>
+              </a:blip>
+              <a:srcRect/>
+              <a:stretch>
+                <a:fillRect/>
+              </a:stretch>
+            </p:blipFill>
+            <p:spPr bwMode="auto">
+              <a:xfrm>
+                <a:off x="2143125" y="300038"/>
+                <a:ext cx="7905750" cy="6257925"/>
+              </a:xfrm>
+              <a:prstGeom prst="rect">
+                <a:avLst/>
+              </a:prstGeom>
+              <a:noFill/>
+              <a:extLst>
+                <a:ext uri="{909E8E84-426E-40DD-AFC4-6F175D3DCCD1}">
+                  <a14:hiddenFill xmlns:a14="http://schemas.microsoft.com/office/drawing/2010/main">
+                    <a:solidFill>
+                      <a:srgbClr val="FFFFFF"/>
+                    </a:solidFill>
+                  </a14:hiddenFill>
+                </a:ext>
+              </a:extLst>
+            </p:spPr>
+          </p:pic>
+          <p:cxnSp>
+            <p:nvCxnSpPr>
+              <p:cNvPr id="4" name="Connector: Elbow 3">
+                <a:extLst>
+                  <a:ext uri="{FF2B5EF4-FFF2-40B4-BE49-F238E27FC236}">
+                    <a16:creationId xmlns:a16="http://schemas.microsoft.com/office/drawing/2014/main" id="{3FFCAD53-28C6-4E38-8AC1-8FCC2DCEDD2A}"/>
+                  </a:ext>
+                </a:extLst>
+              </p:cNvPr>
+              <p:cNvCxnSpPr/>
+              <p:nvPr/>
+            </p:nvCxnSpPr>
+            <p:spPr>
+              <a:xfrm>
+                <a:off x="6858000" y="1320085"/>
+                <a:ext cx="553792" cy="482957"/>
+              </a:xfrm>
+              <a:prstGeom prst="bentConnector3">
+                <a:avLst/>
+              </a:prstGeom>
+              <a:ln>
+                <a:tailEnd type="triangle"/>
+              </a:ln>
+            </p:spPr>
+            <p:style>
+              <a:lnRef idx="3">
+                <a:schemeClr val="dk1"/>
+              </a:lnRef>
+              <a:fillRef idx="0">
+                <a:schemeClr val="dk1"/>
+              </a:fillRef>
+              <a:effectRef idx="2">
+                <a:schemeClr val="dk1"/>
+              </a:effectRef>
+              <a:fontRef idx="minor">
+                <a:schemeClr val="tx1"/>
+              </a:fontRef>
+            </p:style>
+          </p:cxnSp>
+        </p:grpSp>
+        <p:sp>
+          <p:nvSpPr>
+            <p:cNvPr id="6" name="Rectangle 5">
+              <a:extLst>
+                <a:ext uri="{FF2B5EF4-FFF2-40B4-BE49-F238E27FC236}">
+                  <a16:creationId xmlns:a16="http://schemas.microsoft.com/office/drawing/2014/main" id="{527B4EF7-9C2F-6FDA-00E9-3A20D05A9E6E}"/>
+                </a:ext>
+              </a:extLst>
+            </p:cNvPr>
+            <p:cNvSpPr/>
+            <p:nvPr/>
+          </p:nvSpPr>
+          <p:spPr>
+            <a:xfrm>
+              <a:off x="2028423" y="212501"/>
+              <a:ext cx="360608" cy="6458755"/>
+            </a:xfrm>
+            <a:prstGeom prst="rect">
+              <a:avLst/>
+            </a:prstGeom>
+            <a:solidFill>
+              <a:schemeClr val="bg1"/>
+            </a:solidFill>
+            <a:ln>
+              <a:solidFill>
+                <a:schemeClr val="bg1"/>
+              </a:solidFill>
+            </a:ln>
+          </p:spPr>
+          <p:style>
+            <a:lnRef idx="2">
+              <a:schemeClr val="accent1">
+                <a:shade val="15000"/>
+              </a:schemeClr>
+            </a:lnRef>
+            <a:fillRef idx="1">
+              <a:schemeClr val="accent1"/>
+            </a:fillRef>
+            <a:effectRef idx="0">
+              <a:schemeClr val="accent1"/>
+            </a:effectRef>
+            <a:fontRef idx="minor">
+              <a:schemeClr val="lt1"/>
+            </a:fontRef>
+          </p:style>
+          <p:txBody>
+            <a:bodyPr rtlCol="0" anchor="ctr"/>
+            <a:lstStyle/>
+            <a:p>
+              <a:pPr algn="ctr"/>
+              <a:endParaRPr lang="en-US"/>
+            </a:p>
+          </p:txBody>
+        </p:sp>
+      </p:grpSp>
+      <p:sp>
+        <p:nvSpPr>
+          <p:cNvPr id="8" name="TextBox 7">
             <a:extLst>
-              <a:ext uri="{28A0092B-C50C-407E-A947-70E740481C1C}">
-                <a14:useLocalDpi xmlns:a14="http://schemas.microsoft.com/office/drawing/2010/main" val="0"/>
+              <a:ext uri="{FF2B5EF4-FFF2-40B4-BE49-F238E27FC236}">
+                <a16:creationId xmlns:a16="http://schemas.microsoft.com/office/drawing/2014/main" id="{0B2285BE-DCA2-04EC-C2D1-FDBE3078DB9A}"/>
               </a:ext>
             </a:extLst>
-          </a:blip>
-          <a:srcRect/>
-          <a:stretch>
-            <a:fillRect/>
-          </a:stretch>
-        </p:blipFill>
-        <p:spPr bwMode="auto">
+          </p:cNvPr>
+          <p:cNvSpPr txBox="1"/>
+          <p:nvPr/>
+        </p:nvSpPr>
+        <p:spPr>
           <a:xfrm>
-            <a:off x="2143125" y="300038"/>
-            <a:ext cx="7905750" cy="6257925"/>
+            <a:off x="496441" y="953037"/>
+            <a:ext cx="1474631" cy="861774"/>
           </a:xfrm>
           <a:prstGeom prst="rect">
             <a:avLst/>
           </a:prstGeom>
           <a:noFill/>
-          <a:extLst>
-            <a:ext uri="{909E8E84-426E-40DD-AFC4-6F175D3DCCD1}">
-              <a14:hiddenFill xmlns:a14="http://schemas.microsoft.com/office/drawing/2010/main">
-                <a:solidFill>
-                  <a:srgbClr val="FFFFFF"/>
-                </a:solidFill>
-              </a14:hiddenFill>
-            </a:ext>
-          </a:extLst>
         </p:spPr>
-      </p:pic>
+        <p:txBody>
+          <a:bodyPr wrap="square" rtlCol="0">
+            <a:spAutoFit/>
+          </a:bodyPr>
+          <a:lstStyle/>
+          <a:p>
+            <a:r>
+              <a:rPr lang="en-US" sz="1000" dirty="0"/>
+              <a:t>Note:</a:t>
+            </a:r>
+          </a:p>
+          <a:p>
+            <a:endParaRPr lang="en-US" sz="1000" dirty="0"/>
+          </a:p>
+          <a:p>
+            <a:r>
+              <a:rPr lang="en-US" sz="1000" dirty="0"/>
+              <a:t>WG – working group</a:t>
+            </a:r>
+          </a:p>
+          <a:p>
+            <a:r>
+              <a:rPr lang="en-US" sz="1000" dirty="0"/>
+              <a:t>TF – Tasking Force</a:t>
+            </a:r>
+          </a:p>
+          <a:p>
+            <a:r>
+              <a:rPr lang="en-US" sz="1000" dirty="0"/>
+              <a:t>S – Sub-committee</a:t>
+            </a:r>
+          </a:p>
+        </p:txBody>
+      </p:sp>
     </p:spTree>
     <p:extLst>
       <p:ext uri="{BB962C8B-B14F-4D97-AF65-F5344CB8AC3E}">

</xml_diff>